<commit_message>
docs: budget 396 heures, materiel amorti et cout par mission
</commit_message>
<xml_diff>
--- a/docs/rendu/2026-09-23/InfiMatch_Soutenance_2026-09-23.pptx
+++ b/docs/rendu/2026-09-23/InfiMatch_Soutenance_2026-09-23.pptx
@@ -17,6 +17,7 @@
     <p:sldId id="265" r:id="rId17"/>
     <p:sldId id="266" r:id="rId18"/>
     <p:sldId id="267" r:id="rId19"/>
+    <p:sldId id="268" r:id="rId20"/>
   </p:sldIdLst>
   <p:sldSz cx="12192000" cy="6858000" type="screen4x3"/>
   <p:notesSz cx="6858000" cy="9144000"/>
@@ -678,7 +679,7 @@
           </a:p>
           <a:p>
             <a:r>
-              <a:t>Ne pas présenter les durées d’agent comme du travail humain. Quatre personnes, onze jours, six heures productives hypothétiques donnent 264 h : l’écart doit être expliqué par le réel, pas masqué. La validation du CDC à J+2 reste à joindre.</a:t>
+              <a:t>Déclaration équipe : 4 × 11 × (7 + environ 2) = 396 h, 99 par personne. APEC : 41 000 EUR brut/an, taux 41 000/1 820 = 22,52747 EUR/h. Charges patronales hypothétiques +42 %, pas un taux officiel. Matériel : 4 × 2 000 EUR, amorti sur trois ans et affecté 11/220 jours par an = 133,33 EUR. Les 8 000 EUR d’achat ne sont pas additionnés à l’amortissement. Le total économique 12 800,98 EUR exclut les abonnements historiques inconnus et éventuelles majorations du soir. Voir 09_COUTS_PRODUCTION.md.</a:t>
             </a:r>
           </a:p>
           <a:p>
@@ -753,12 +754,92 @@
           <a:lstStyle/>
           <a:p>
             <a:r>
-              <a:t>Intervenant D - 75 secondes.</a:t>
-            </a:r>
-          </a:p>
-          <a:p>
-            <a:r>
-              <a:t>Conclure sur la proposition de valeur, puis ouvrir les questions. Les entretiens et partenariats ne sont pas acquis. Supabase/PostGIS attend le support ; DNS local inchangé. Le coffre local a été réparé. Montrer que les réserves sont connues et suivies.</a:t>
+              <a:t>Intervenant D - 45 secondes.</a:t>
+            </a:r>
+          </a:p>
+          <a:p>
+            <a:r>
+              <a:t>Services : Vercel20, Supabase25, Atlas58,40, n8n50, SMTP2GO10, JobsPipe49, GitHub16 et provisions36,67 EUR. USD converti conventionnellement à parité, pas au cours constaté. n8n payé annuellement. Charges employeur supposées +42 % sur 41 000 EUR brut/an. Poste 2 000 EUR/36mois. Coût moyen, pas marginal. Hypothèse n8n : (300 tâches de fond + 8 exécutions par validation) ×1,1, soit 9 130 à 1 000 validations. À 80 % de conversion, le quota est dépassé. Sources et exclusions : 09_COUTS_PRODUCTION.md.</a:t>
+            </a:r>
+          </a:p>
+          <a:p>
+            <a:r>
+              <a:t>Voir 05_ETUDE_DE_MARCHE.md pour les sources et 07_PITCH_ORAL.md pour le scénario de secours.</a:t>
+            </a:r>
+          </a:p>
+        </p:txBody>
+      </p:sp>
+      <p:sp>
+        <p:nvSpPr>
+          <p:cNvPr id="4" name="Slide Number Placeholder 3"/>
+          <p:cNvSpPr>
+            <a:spLocks noGrp="1"/>
+          </p:cNvSpPr>
+          <p:nvPr>
+            <p:ph type="sldNum" idx="5" sz="quarter"/>
+          </p:nvPr>
+        </p:nvSpPr>
+        <p:spPr/>
+      </p:sp>
+    </p:spTree>
+  </p:cSld>
+  <p:clrMapOvr>
+    <a:masterClrMapping/>
+  </p:clrMapOvr>
+</p:notes>
+</file>
+
+<file path=ppt/notesSlides/notesSlide13.xml><?xml version="1.0" encoding="utf-8"?>
+<p:notes xmlns:a="http://schemas.openxmlformats.org/drawingml/2006/main" xmlns:p="http://schemas.openxmlformats.org/presentationml/2006/main" xmlns:r="http://schemas.openxmlformats.org/officeDocument/2006/relationships">
+  <p:cSld>
+    <p:spTree>
+      <p:nvGrpSpPr>
+        <p:cNvPr id="1" name=""/>
+        <p:cNvGrpSpPr/>
+        <p:nvPr/>
+      </p:nvGrpSpPr>
+      <p:grpSpPr>
+        <a:xfrm>
+          <a:off x="0" y="0"/>
+          <a:ext cx="0" cy="0"/>
+          <a:chOff x="0" y="0"/>
+          <a:chExt cx="0" cy="0"/>
+        </a:xfrm>
+      </p:grpSpPr>
+      <p:sp>
+        <p:nvSpPr>
+          <p:cNvPr id="2" name="Slide Image Placeholder 1"/>
+          <p:cNvSpPr>
+            <a:spLocks noGrp="1"/>
+          </p:cNvSpPr>
+          <p:nvPr>
+            <p:ph type="sldImg" idx="2"/>
+          </p:nvPr>
+        </p:nvSpPr>
+        <p:spPr/>
+      </p:sp>
+      <p:sp>
+        <p:nvSpPr>
+          <p:cNvPr id="3" name="Notes Placeholder 2"/>
+          <p:cNvSpPr>
+            <a:spLocks noGrp="1"/>
+          </p:cNvSpPr>
+          <p:nvPr>
+            <p:ph type="body" idx="3" sz="quarter"/>
+          </p:nvPr>
+        </p:nvSpPr>
+        <p:spPr/>
+        <p:txBody>
+          <a:bodyPr/>
+          <a:lstStyle/>
+          <a:p>
+            <a:r>
+              <a:t>Intervenant D - 30 secondes.</a:t>
+            </a:r>
+          </a:p>
+          <a:p>
+            <a:r>
+              <a:t>Conclure sur la proposition de valeur, puis ouvrir les questions. Les entretiens et partenariats ne sont pas acquis. Supabase/PostGIS attend le support ; DNS local inchangé. Le coffre local a été réparé. Montrer que les réserves sont connues et suivies. Total déclaré : environ 396 h ; ventilation à compléter.</a:t>
             </a:r>
           </a:p>
           <a:p>
@@ -5040,7 +5121,7 @@
               </a:defRPr>
             </a:pPr>
             <a:r>
-              <a:t>Projet étudiant · État documentaire au 23 septembre 2026 · Réserves et sources : 05_ETUDE_DE_MARCHE.md</a:t>
+              <a:t>Projet étudiant · État documentaire au 24 septembre 2026 · Sources : étude de marché et 09_COUTS_PRODUCTION.md</a:t>
             </a:r>
           </a:p>
         </p:txBody>
@@ -5082,7 +5163,7 @@
               </a:defRPr>
             </a:pPr>
             <a:r>
-              <a:t>01 / 12</a:t>
+              <a:t>01 / 13</a:t>
             </a:r>
           </a:p>
         </p:txBody>
@@ -5736,7 +5817,7 @@
               </a:defRPr>
             </a:pPr>
             <a:r>
-              <a:t>Projet étudiant · État documentaire au 23 septembre 2026 · Réserves et sources : 05_ETUDE_DE_MARCHE.md</a:t>
+              <a:t>Projet étudiant · État documentaire au 24 septembre 2026 · Sources : étude de marché et 09_COUTS_PRODUCTION.md</a:t>
             </a:r>
           </a:p>
         </p:txBody>
@@ -5778,7 +5859,7 @@
               </a:defRPr>
             </a:pPr>
             <a:r>
-              <a:t>10 / 12</a:t>
+              <a:t>10 / 13</a:t>
             </a:r>
           </a:p>
         </p:txBody>
@@ -6008,7 +6089,7 @@
               </a:defRPr>
             </a:pPr>
             <a:r>
-              <a:t>Confronter le prévu au réalisé</a:t>
+              <a:t>396 heures déclarées, un coût explicite</a:t>
             </a:r>
           </a:p>
         </p:txBody>
@@ -6050,7 +6131,7 @@
               </a:defRPr>
             </a:pPr>
             <a:r>
-              <a:t>Quatre personnes • Onze jours • Dix-huit lots</a:t>
+              <a:t>4 personnes • 11 jours • journée et travail du soir</a:t>
             </a:r>
           </a:p>
         </p:txBody>
@@ -6178,7 +6259,7 @@
               </a:defRPr>
             </a:pPr>
             <a:r>
-              <a:t>Estimation conservée</a:t>
+              <a:t>Charge reconstituée</a:t>
             </a:r>
           </a:p>
         </p:txBody>
@@ -6220,7 +6301,7 @@
               </a:defRPr>
             </a:pPr>
             <a:r>
-              <a:t>348 à 528 heures-personnes. 438 h est le centre calculé, pas une nouvelle estimation validée à J+2.</a:t>
+              <a:t>308 h de journée + 88 h le soir = environ 396 h. Capacité prévue à cinq : 385 h. Écart : +11 h. Répartition par fonctionnalité à compléter.</a:t>
             </a:r>
           </a:p>
         </p:txBody>
@@ -6348,7 +6429,7 @@
               </a:defRPr>
             </a:pPr>
             <a:r>
-              <a:t>Réalisé à documenter</a:t>
+              <a:t>Réalisation et matériel</a:t>
             </a:r>
           </a:p>
         </p:txBody>
@@ -6390,7 +6471,7 @@
               </a:defRPr>
             </a:pPr>
             <a:r>
-              <a:t>Le relevé humain est vide. Le classeur calcule les écarts après saisie des heures et justificatifs.</a:t>
+              <a:t>Travail brut : 8 920,88 EUR. Matériel amorti : 133,33 EUR. Avec charges estimées : 12 800,98 EUR. Achat des quatre postes : 8 000 EUR, distinct du coût imputé.</a:t>
             </a:r>
           </a:p>
         </p:txBody>
@@ -6432,7 +6513,7 @@
               </a:defRPr>
             </a:pPr>
             <a:r>
-              <a:t>Projet étudiant · État documentaire au 23 septembre 2026 · Réserves et sources : 05_ETUDE_DE_MARCHE.md</a:t>
+              <a:t>Projet étudiant · État documentaire au 24 septembre 2026 · Sources : étude de marché et 09_COUTS_PRODUCTION.md</a:t>
             </a:r>
           </a:p>
         </p:txBody>
@@ -6474,7 +6555,7 @@
               </a:defRPr>
             </a:pPr>
             <a:r>
-              <a:t>11 / 12</a:t>
+              <a:t>11 / 13</a:t>
             </a:r>
           </a:p>
         </p:txBody>
@@ -6662,7 +6743,7 @@
               </a:defRPr>
             </a:pPr>
             <a:r>
-              <a:t>12 / LA SUITE</a:t>
+              <a:t>12 / EXPLOITATION</a:t>
             </a:r>
           </a:p>
         </p:txBody>
@@ -6704,7 +6785,7 @@
               </a:defRPr>
             </a:pPr>
             <a:r>
-              <a:t>Un POC démontrable, un pilote à valider</a:t>
+              <a:t>Le coût baisse avec les missions validées</a:t>
             </a:r>
           </a:p>
         </p:txBody>
@@ -6746,7 +6827,7 @@
               </a:defRPr>
             </a:pPr>
             <a:r>
-              <a:t>Preuve technique disponible ; validation marché encore à mener</a:t>
+              <a:t>Budget prospectif • maintenance à temps plein • matériel inclus</a:t>
             </a:r>
           </a:p>
         </p:txBody>
@@ -6874,7 +6955,7 @@
               </a:defRPr>
             </a:pPr>
             <a:r>
-              <a:t>Livraison</a:t>
+              <a:t>5 265,30 EUR par mois</a:t>
             </a:r>
           </a:p>
         </p:txBody>
@@ -6916,7 +6997,7 @@
               </a:defRPr>
             </a:pPr>
             <a:r>
-              <a:t>Code, README, roadmap, exports n8n, script FINESS, étude sourcée, classeur et support oral.</a:t>
+              <a:t>Maintenance : 4 851,67 EUR. Services : 265,07 EUR. Réserve : 53,01 EUR. Matériel amorti : 55,56 EUR. Connexion et énergie : 40 EUR.</a:t>
             </a:r>
           </a:p>
         </p:txBody>
@@ -7044,7 +7125,7 @@
               </a:defRPr>
             </a:pPr>
             <a:r>
-              <a:t>Prochaines étapes</a:t>
+              <a:t>Coût moyen par validation</a:t>
             </a:r>
           </a:p>
         </p:txBody>
@@ -7086,7 +7167,7 @@
               </a:defRPr>
             </a:pPr>
             <a:r>
-              <a:t>Renseigner les temps. Tester le besoin sur le terrain. Suivre PostGIS avec Supabase et le DNS local. Préparer un pilote limité.</a:t>
+              <a:t>100 missions/mois : 52,65 EUR. 500 missions/mois : 10,53 EUR. 1 000 missions/mois : 5,27 EUR. Hors dépassements et temps du recruteur.</a:t>
             </a:r>
           </a:p>
         </p:txBody>
@@ -7128,7 +7209,7 @@
               </a:defRPr>
             </a:pPr>
             <a:r>
-              <a:t>Projet étudiant · État documentaire au 23 septembre 2026 · Réserves et sources : 05_ETUDE_DE_MARCHE.md</a:t>
+              <a:t>Projet étudiant · État documentaire au 24 septembre 2026 · Sources : étude de marché et 09_COUTS_PRODUCTION.md</a:t>
             </a:r>
           </a:p>
         </p:txBody>
@@ -7170,7 +7251,703 @@
               </a:defRPr>
             </a:pPr>
             <a:r>
-              <a:t>12 / 12</a:t>
+              <a:t>12 / 13</a:t>
+            </a:r>
+          </a:p>
+        </p:txBody>
+      </p:sp>
+    </p:spTree>
+  </p:cSld>
+  <p:clrMapOvr>
+    <a:masterClrMapping/>
+  </p:clrMapOvr>
+</p:sld>
+</file>
+
+<file path=ppt/slides/slide13.xml><?xml version="1.0" encoding="utf-8"?>
+<p:sld xmlns:a="http://schemas.openxmlformats.org/drawingml/2006/main" xmlns:p="http://schemas.openxmlformats.org/presentationml/2006/main" xmlns:r="http://schemas.openxmlformats.org/officeDocument/2006/relationships">
+  <p:cSld>
+    <p:spTree>
+      <p:nvGrpSpPr>
+        <p:cNvPr id="1" name=""/>
+        <p:cNvGrpSpPr/>
+        <p:nvPr/>
+      </p:nvGrpSpPr>
+      <p:grpSpPr/>
+      <p:sp>
+        <p:nvSpPr>
+          <p:cNvPr id="2" name="Rectangle 1"/>
+          <p:cNvSpPr/>
+          <p:nvPr/>
+        </p:nvSpPr>
+        <p:spPr>
+          <a:xfrm>
+            <a:off x="0" y="0"/>
+            <a:ext cx="12192000" cy="6858000"/>
+          </a:xfrm>
+          <a:prstGeom prst="rect">
+            <a:avLst/>
+          </a:prstGeom>
+          <a:solidFill>
+            <a:srgbClr val="F3F8FC"/>
+          </a:solidFill>
+          <a:ln>
+            <a:noFill/>
+          </a:ln>
+        </p:spPr>
+        <p:style>
+          <a:lnRef idx="1">
+            <a:schemeClr val="accent1"/>
+          </a:lnRef>
+          <a:fillRef idx="3">
+            <a:schemeClr val="accent1"/>
+          </a:fillRef>
+          <a:effectRef idx="2">
+            <a:schemeClr val="accent1"/>
+          </a:effectRef>
+          <a:fontRef idx="minor">
+            <a:schemeClr val="lt1"/>
+          </a:fontRef>
+        </p:style>
+        <p:txBody>
+          <a:bodyPr rtlCol="0" anchor="ctr"/>
+          <a:lstStyle/>
+          <a:p>
+            <a:pPr algn="ctr"/>
+          </a:p>
+        </p:txBody>
+      </p:sp>
+      <p:sp>
+        <p:nvSpPr>
+          <p:cNvPr id="3" name="Rectangle 2"/>
+          <p:cNvSpPr/>
+          <p:nvPr/>
+        </p:nvSpPr>
+        <p:spPr>
+          <a:xfrm>
+            <a:off x="0" y="0"/>
+            <a:ext cx="152400" cy="6858000"/>
+          </a:xfrm>
+          <a:prstGeom prst="rect">
+            <a:avLst/>
+          </a:prstGeom>
+          <a:solidFill>
+            <a:srgbClr val="155EE8"/>
+          </a:solidFill>
+          <a:ln>
+            <a:noFill/>
+          </a:ln>
+        </p:spPr>
+        <p:style>
+          <a:lnRef idx="1">
+            <a:schemeClr val="accent1"/>
+          </a:lnRef>
+          <a:fillRef idx="3">
+            <a:schemeClr val="accent1"/>
+          </a:fillRef>
+          <a:effectRef idx="2">
+            <a:schemeClr val="accent1"/>
+          </a:effectRef>
+          <a:fontRef idx="minor">
+            <a:schemeClr val="lt1"/>
+          </a:fontRef>
+        </p:style>
+        <p:txBody>
+          <a:bodyPr rtlCol="0" anchor="ctr"/>
+          <a:lstStyle/>
+          <a:p>
+            <a:pPr algn="ctr"/>
+          </a:p>
+        </p:txBody>
+      </p:sp>
+      <p:sp>
+        <p:nvSpPr>
+          <p:cNvPr id="4" name="TextBox 3"/>
+          <p:cNvSpPr txBox="1"/>
+          <p:nvPr/>
+        </p:nvSpPr>
+        <p:spPr>
+          <a:xfrm>
+            <a:off x="609600" y="304800"/>
+            <a:ext cx="3048000" cy="355600"/>
+          </a:xfrm>
+          <a:prstGeom prst="rect">
+            <a:avLst/>
+          </a:prstGeom>
+          <a:noFill/>
+        </p:spPr>
+        <p:txBody>
+          <a:bodyPr wrap="square" lIns="0" rIns="0" tIns="0" bIns="0">
+            <a:spAutoFit/>
+          </a:bodyPr>
+          <a:lstStyle/>
+          <a:p>
+            <a:pPr>
+              <a:lnSpc>
+                <a:spcPct val="115000"/>
+              </a:lnSpc>
+              <a:spcAft>
+                <a:spcPts val="0"/>
+              </a:spcAft>
+              <a:defRPr sz="2200" b="1">
+                <a:solidFill>
+                  <a:srgbClr val="082F49"/>
+                </a:solidFill>
+                <a:latin typeface="Arial"/>
+              </a:defRPr>
+            </a:pPr>
+            <a:r>
+              <a:t>InfiMatch</a:t>
+            </a:r>
+          </a:p>
+        </p:txBody>
+      </p:sp>
+      <p:sp>
+        <p:nvSpPr>
+          <p:cNvPr id="5" name="TextBox 4"/>
+          <p:cNvSpPr txBox="1"/>
+          <p:nvPr/>
+        </p:nvSpPr>
+        <p:spPr>
+          <a:xfrm>
+            <a:off x="8255000" y="368300"/>
+            <a:ext cx="3352800" cy="254000"/>
+          </a:xfrm>
+          <a:prstGeom prst="rect">
+            <a:avLst/>
+          </a:prstGeom>
+          <a:noFill/>
+        </p:spPr>
+        <p:txBody>
+          <a:bodyPr wrap="square" lIns="0" rIns="0" tIns="0" bIns="0">
+            <a:spAutoFit/>
+          </a:bodyPr>
+          <a:lstStyle/>
+          <a:p>
+            <a:pPr>
+              <a:lnSpc>
+                <a:spcPct val="115000"/>
+              </a:lnSpc>
+              <a:spcAft>
+                <a:spcPts val="0"/>
+              </a:spcAft>
+              <a:defRPr sz="1100" b="1">
+                <a:solidFill>
+                  <a:srgbClr val="435F72"/>
+                </a:solidFill>
+                <a:latin typeface="Arial"/>
+              </a:defRPr>
+            </a:pPr>
+            <a:r>
+              <a:t>13 / LA SUITE</a:t>
+            </a:r>
+          </a:p>
+        </p:txBody>
+      </p:sp>
+      <p:sp>
+        <p:nvSpPr>
+          <p:cNvPr id="6" name="TextBox 5"/>
+          <p:cNvSpPr txBox="1"/>
+          <p:nvPr/>
+        </p:nvSpPr>
+        <p:spPr>
+          <a:xfrm>
+            <a:off x="609600" y="1016000"/>
+            <a:ext cx="10896600" cy="1092200"/>
+          </a:xfrm>
+          <a:prstGeom prst="rect">
+            <a:avLst/>
+          </a:prstGeom>
+          <a:noFill/>
+        </p:spPr>
+        <p:txBody>
+          <a:bodyPr wrap="square" lIns="0" rIns="0" tIns="0" bIns="0">
+            <a:spAutoFit/>
+          </a:bodyPr>
+          <a:lstStyle/>
+          <a:p>
+            <a:pPr>
+              <a:lnSpc>
+                <a:spcPct val="115000"/>
+              </a:lnSpc>
+              <a:spcAft>
+                <a:spcPts val="0"/>
+              </a:spcAft>
+              <a:defRPr sz="3400" b="1">
+                <a:solidFill>
+                  <a:srgbClr val="082F49"/>
+                </a:solidFill>
+                <a:latin typeface="Arial"/>
+              </a:defRPr>
+            </a:pPr>
+            <a:r>
+              <a:t>Un POC démontrable, un pilote à valider</a:t>
+            </a:r>
+          </a:p>
+        </p:txBody>
+      </p:sp>
+      <p:sp>
+        <p:nvSpPr>
+          <p:cNvPr id="7" name="TextBox 6"/>
+          <p:cNvSpPr txBox="1"/>
+          <p:nvPr/>
+        </p:nvSpPr>
+        <p:spPr>
+          <a:xfrm>
+            <a:off x="635000" y="2070100"/>
+            <a:ext cx="10795000" cy="355600"/>
+          </a:xfrm>
+          <a:prstGeom prst="rect">
+            <a:avLst/>
+          </a:prstGeom>
+          <a:noFill/>
+        </p:spPr>
+        <p:txBody>
+          <a:bodyPr wrap="square" lIns="0" rIns="0" tIns="0" bIns="0">
+            <a:spAutoFit/>
+          </a:bodyPr>
+          <a:lstStyle/>
+          <a:p>
+            <a:pPr>
+              <a:lnSpc>
+                <a:spcPct val="115000"/>
+              </a:lnSpc>
+              <a:spcAft>
+                <a:spcPts val="0"/>
+              </a:spcAft>
+              <a:defRPr sz="1600" b="0">
+                <a:solidFill>
+                  <a:srgbClr val="435F72"/>
+                </a:solidFill>
+                <a:latin typeface="Arial"/>
+              </a:defRPr>
+            </a:pPr>
+            <a:r>
+              <a:t>Preuve technique disponible ; validation marché encore à mener</a:t>
+            </a:r>
+          </a:p>
+        </p:txBody>
+      </p:sp>
+      <p:sp>
+        <p:nvSpPr>
+          <p:cNvPr id="8" name="Rectangle 7"/>
+          <p:cNvSpPr/>
+          <p:nvPr/>
+        </p:nvSpPr>
+        <p:spPr>
+          <a:xfrm>
+            <a:off x="609600" y="2692400"/>
+            <a:ext cx="5321300" cy="3073400"/>
+          </a:xfrm>
+          <a:prstGeom prst="rect">
+            <a:avLst/>
+          </a:prstGeom>
+          <a:solidFill>
+            <a:srgbClr val="FFFFFF"/>
+          </a:solidFill>
+          <a:ln>
+            <a:noFill/>
+          </a:ln>
+        </p:spPr>
+        <p:style>
+          <a:lnRef idx="1">
+            <a:schemeClr val="accent1"/>
+          </a:lnRef>
+          <a:fillRef idx="3">
+            <a:schemeClr val="accent1"/>
+          </a:fillRef>
+          <a:effectRef idx="2">
+            <a:schemeClr val="accent1"/>
+          </a:effectRef>
+          <a:fontRef idx="minor">
+            <a:schemeClr val="lt1"/>
+          </a:fontRef>
+        </p:style>
+        <p:txBody>
+          <a:bodyPr rtlCol="0" anchor="ctr"/>
+          <a:lstStyle/>
+          <a:p>
+            <a:pPr algn="ctr"/>
+          </a:p>
+        </p:txBody>
+      </p:sp>
+      <p:sp>
+        <p:nvSpPr>
+          <p:cNvPr id="9" name="Rectangle 8"/>
+          <p:cNvSpPr/>
+          <p:nvPr/>
+        </p:nvSpPr>
+        <p:spPr>
+          <a:xfrm>
+            <a:off x="609600" y="2692400"/>
+            <a:ext cx="5321300" cy="50800"/>
+          </a:xfrm>
+          <a:prstGeom prst="rect">
+            <a:avLst/>
+          </a:prstGeom>
+          <a:solidFill>
+            <a:srgbClr val="155EE8"/>
+          </a:solidFill>
+          <a:ln>
+            <a:noFill/>
+          </a:ln>
+        </p:spPr>
+        <p:style>
+          <a:lnRef idx="1">
+            <a:schemeClr val="accent1"/>
+          </a:lnRef>
+          <a:fillRef idx="3">
+            <a:schemeClr val="accent1"/>
+          </a:fillRef>
+          <a:effectRef idx="2">
+            <a:schemeClr val="accent1"/>
+          </a:effectRef>
+          <a:fontRef idx="minor">
+            <a:schemeClr val="lt1"/>
+          </a:fontRef>
+        </p:style>
+        <p:txBody>
+          <a:bodyPr rtlCol="0" anchor="ctr"/>
+          <a:lstStyle/>
+          <a:p>
+            <a:pPr algn="ctr"/>
+          </a:p>
+        </p:txBody>
+      </p:sp>
+      <p:sp>
+        <p:nvSpPr>
+          <p:cNvPr id="10" name="TextBox 9"/>
+          <p:cNvSpPr txBox="1"/>
+          <p:nvPr/>
+        </p:nvSpPr>
+        <p:spPr>
+          <a:xfrm>
+            <a:off x="889000" y="2984500"/>
+            <a:ext cx="4762500" cy="673100"/>
+          </a:xfrm>
+          <a:prstGeom prst="rect">
+            <a:avLst/>
+          </a:prstGeom>
+          <a:noFill/>
+        </p:spPr>
+        <p:txBody>
+          <a:bodyPr wrap="square" lIns="0" rIns="0" tIns="0" bIns="0">
+            <a:spAutoFit/>
+          </a:bodyPr>
+          <a:lstStyle/>
+          <a:p>
+            <a:pPr>
+              <a:lnSpc>
+                <a:spcPct val="115000"/>
+              </a:lnSpc>
+              <a:spcAft>
+                <a:spcPts val="0"/>
+              </a:spcAft>
+              <a:defRPr sz="2100" b="1">
+                <a:solidFill>
+                  <a:srgbClr val="082F49"/>
+                </a:solidFill>
+                <a:latin typeface="Arial"/>
+              </a:defRPr>
+            </a:pPr>
+            <a:r>
+              <a:t>Livraison</a:t>
+            </a:r>
+          </a:p>
+        </p:txBody>
+      </p:sp>
+      <p:sp>
+        <p:nvSpPr>
+          <p:cNvPr id="11" name="TextBox 10"/>
+          <p:cNvSpPr txBox="1"/>
+          <p:nvPr/>
+        </p:nvSpPr>
+        <p:spPr>
+          <a:xfrm>
+            <a:off x="889000" y="3733800"/>
+            <a:ext cx="4762500" cy="1816100"/>
+          </a:xfrm>
+          <a:prstGeom prst="rect">
+            <a:avLst/>
+          </a:prstGeom>
+          <a:noFill/>
+        </p:spPr>
+        <p:txBody>
+          <a:bodyPr wrap="square" lIns="0" rIns="0" tIns="0" bIns="0">
+            <a:spAutoFit/>
+          </a:bodyPr>
+          <a:lstStyle/>
+          <a:p>
+            <a:pPr>
+              <a:lnSpc>
+                <a:spcPct val="115000"/>
+              </a:lnSpc>
+              <a:spcAft>
+                <a:spcPts val="0"/>
+              </a:spcAft>
+              <a:defRPr sz="1700" b="0">
+                <a:solidFill>
+                  <a:srgbClr val="163B50"/>
+                </a:solidFill>
+                <a:latin typeface="Arial"/>
+              </a:defRPr>
+            </a:pPr>
+            <a:r>
+              <a:t>Code, README, roadmap, exports n8n, script FINESS, étude sourcée, classeur et support oral.</a:t>
+            </a:r>
+          </a:p>
+        </p:txBody>
+      </p:sp>
+      <p:sp>
+        <p:nvSpPr>
+          <p:cNvPr id="12" name="Rectangle 11"/>
+          <p:cNvSpPr/>
+          <p:nvPr/>
+        </p:nvSpPr>
+        <p:spPr>
+          <a:xfrm>
+            <a:off x="6261100" y="2692400"/>
+            <a:ext cx="5321300" cy="3073400"/>
+          </a:xfrm>
+          <a:prstGeom prst="rect">
+            <a:avLst/>
+          </a:prstGeom>
+          <a:solidFill>
+            <a:srgbClr val="FFFFFF"/>
+          </a:solidFill>
+          <a:ln>
+            <a:noFill/>
+          </a:ln>
+        </p:spPr>
+        <p:style>
+          <a:lnRef idx="1">
+            <a:schemeClr val="accent1"/>
+          </a:lnRef>
+          <a:fillRef idx="3">
+            <a:schemeClr val="accent1"/>
+          </a:fillRef>
+          <a:effectRef idx="2">
+            <a:schemeClr val="accent1"/>
+          </a:effectRef>
+          <a:fontRef idx="minor">
+            <a:schemeClr val="lt1"/>
+          </a:fontRef>
+        </p:style>
+        <p:txBody>
+          <a:bodyPr rtlCol="0" anchor="ctr"/>
+          <a:lstStyle/>
+          <a:p>
+            <a:pPr algn="ctr"/>
+          </a:p>
+        </p:txBody>
+      </p:sp>
+      <p:sp>
+        <p:nvSpPr>
+          <p:cNvPr id="13" name="Rectangle 12"/>
+          <p:cNvSpPr/>
+          <p:nvPr/>
+        </p:nvSpPr>
+        <p:spPr>
+          <a:xfrm>
+            <a:off x="6261100" y="2692400"/>
+            <a:ext cx="5321300" cy="50800"/>
+          </a:xfrm>
+          <a:prstGeom prst="rect">
+            <a:avLst/>
+          </a:prstGeom>
+          <a:solidFill>
+            <a:srgbClr val="155EE8"/>
+          </a:solidFill>
+          <a:ln>
+            <a:noFill/>
+          </a:ln>
+        </p:spPr>
+        <p:style>
+          <a:lnRef idx="1">
+            <a:schemeClr val="accent1"/>
+          </a:lnRef>
+          <a:fillRef idx="3">
+            <a:schemeClr val="accent1"/>
+          </a:fillRef>
+          <a:effectRef idx="2">
+            <a:schemeClr val="accent1"/>
+          </a:effectRef>
+          <a:fontRef idx="minor">
+            <a:schemeClr val="lt1"/>
+          </a:fontRef>
+        </p:style>
+        <p:txBody>
+          <a:bodyPr rtlCol="0" anchor="ctr"/>
+          <a:lstStyle/>
+          <a:p>
+            <a:pPr algn="ctr"/>
+          </a:p>
+        </p:txBody>
+      </p:sp>
+      <p:sp>
+        <p:nvSpPr>
+          <p:cNvPr id="14" name="TextBox 13"/>
+          <p:cNvSpPr txBox="1"/>
+          <p:nvPr/>
+        </p:nvSpPr>
+        <p:spPr>
+          <a:xfrm>
+            <a:off x="6540500" y="2984500"/>
+            <a:ext cx="4762500" cy="673100"/>
+          </a:xfrm>
+          <a:prstGeom prst="rect">
+            <a:avLst/>
+          </a:prstGeom>
+          <a:noFill/>
+        </p:spPr>
+        <p:txBody>
+          <a:bodyPr wrap="square" lIns="0" rIns="0" tIns="0" bIns="0">
+            <a:spAutoFit/>
+          </a:bodyPr>
+          <a:lstStyle/>
+          <a:p>
+            <a:pPr>
+              <a:lnSpc>
+                <a:spcPct val="115000"/>
+              </a:lnSpc>
+              <a:spcAft>
+                <a:spcPts val="0"/>
+              </a:spcAft>
+              <a:defRPr sz="2100" b="1">
+                <a:solidFill>
+                  <a:srgbClr val="082F49"/>
+                </a:solidFill>
+                <a:latin typeface="Arial"/>
+              </a:defRPr>
+            </a:pPr>
+            <a:r>
+              <a:t>Prochaines étapes</a:t>
+            </a:r>
+          </a:p>
+        </p:txBody>
+      </p:sp>
+      <p:sp>
+        <p:nvSpPr>
+          <p:cNvPr id="15" name="TextBox 14"/>
+          <p:cNvSpPr txBox="1"/>
+          <p:nvPr/>
+        </p:nvSpPr>
+        <p:spPr>
+          <a:xfrm>
+            <a:off x="6540500" y="3733800"/>
+            <a:ext cx="4762500" cy="1816100"/>
+          </a:xfrm>
+          <a:prstGeom prst="rect">
+            <a:avLst/>
+          </a:prstGeom>
+          <a:noFill/>
+        </p:spPr>
+        <p:txBody>
+          <a:bodyPr wrap="square" lIns="0" rIns="0" tIns="0" bIns="0">
+            <a:spAutoFit/>
+          </a:bodyPr>
+          <a:lstStyle/>
+          <a:p>
+            <a:pPr>
+              <a:lnSpc>
+                <a:spcPct val="115000"/>
+              </a:lnSpc>
+              <a:spcAft>
+                <a:spcPts val="0"/>
+              </a:spcAft>
+              <a:defRPr sz="1700" b="0">
+                <a:solidFill>
+                  <a:srgbClr val="163B50"/>
+                </a:solidFill>
+                <a:latin typeface="Arial"/>
+              </a:defRPr>
+            </a:pPr>
+            <a:r>
+              <a:t>Ventiler les 396 h. Tester le besoin sur le terrain. Suivre PostGIS avec Supabase et le DNS local. Préparer un pilote limité.</a:t>
+            </a:r>
+          </a:p>
+        </p:txBody>
+      </p:sp>
+      <p:sp>
+        <p:nvSpPr>
+          <p:cNvPr id="16" name="TextBox 15"/>
+          <p:cNvSpPr txBox="1"/>
+          <p:nvPr/>
+        </p:nvSpPr>
+        <p:spPr>
+          <a:xfrm>
+            <a:off x="609600" y="6159500"/>
+            <a:ext cx="10731500" cy="254000"/>
+          </a:xfrm>
+          <a:prstGeom prst="rect">
+            <a:avLst/>
+          </a:prstGeom>
+          <a:noFill/>
+        </p:spPr>
+        <p:txBody>
+          <a:bodyPr wrap="square" lIns="0" rIns="0" tIns="0" bIns="0">
+            <a:spAutoFit/>
+          </a:bodyPr>
+          <a:lstStyle/>
+          <a:p>
+            <a:pPr>
+              <a:lnSpc>
+                <a:spcPct val="115000"/>
+              </a:lnSpc>
+              <a:spcAft>
+                <a:spcPts val="0"/>
+              </a:spcAft>
+              <a:defRPr sz="1000" b="0">
+                <a:solidFill>
+                  <a:srgbClr val="435F72"/>
+                </a:solidFill>
+                <a:latin typeface="Arial"/>
+              </a:defRPr>
+            </a:pPr>
+            <a:r>
+              <a:t>Projet étudiant · État documentaire au 24 septembre 2026 · Sources : étude de marché et 09_COUTS_PRODUCTION.md</a:t>
+            </a:r>
+          </a:p>
+        </p:txBody>
+      </p:sp>
+      <p:sp>
+        <p:nvSpPr>
+          <p:cNvPr id="17" name="TextBox 16"/>
+          <p:cNvSpPr txBox="1"/>
+          <p:nvPr/>
+        </p:nvSpPr>
+        <p:spPr>
+          <a:xfrm>
+            <a:off x="10642600" y="6464300"/>
+            <a:ext cx="952500" cy="215900"/>
+          </a:xfrm>
+          <a:prstGeom prst="rect">
+            <a:avLst/>
+          </a:prstGeom>
+          <a:noFill/>
+        </p:spPr>
+        <p:txBody>
+          <a:bodyPr wrap="square" lIns="0" rIns="0" tIns="0" bIns="0">
+            <a:spAutoFit/>
+          </a:bodyPr>
+          <a:lstStyle/>
+          <a:p>
+            <a:pPr>
+              <a:lnSpc>
+                <a:spcPct val="115000"/>
+              </a:lnSpc>
+              <a:spcAft>
+                <a:spcPts val="0"/>
+              </a:spcAft>
+              <a:defRPr sz="1000" b="1">
+                <a:solidFill>
+                  <a:srgbClr val="155EE8"/>
+                </a:solidFill>
+                <a:latin typeface="Arial"/>
+              </a:defRPr>
+            </a:pPr>
+            <a:r>
+              <a:t>13 / 13</a:t>
             </a:r>
           </a:p>
         </p:txBody>
@@ -7824,7 +8601,7 @@
               </a:defRPr>
             </a:pPr>
             <a:r>
-              <a:t>Projet étudiant · État documentaire au 23 septembre 2026 · Réserves et sources : 05_ETUDE_DE_MARCHE.md</a:t>
+              <a:t>Projet étudiant · État documentaire au 24 septembre 2026 · Sources : étude de marché et 09_COUTS_PRODUCTION.md</a:t>
             </a:r>
           </a:p>
         </p:txBody>
@@ -7866,7 +8643,7 @@
               </a:defRPr>
             </a:pPr>
             <a:r>
-              <a:t>02 / 12</a:t>
+              <a:t>02 / 13</a:t>
             </a:r>
           </a:p>
         </p:txBody>
@@ -8520,7 +9297,7 @@
               </a:defRPr>
             </a:pPr>
             <a:r>
-              <a:t>Projet étudiant · État documentaire au 23 septembre 2026 · Réserves et sources : 05_ETUDE_DE_MARCHE.md</a:t>
+              <a:t>Projet étudiant · État documentaire au 24 septembre 2026 · Sources : étude de marché et 09_COUTS_PRODUCTION.md</a:t>
             </a:r>
           </a:p>
         </p:txBody>
@@ -8562,7 +9339,7 @@
               </a:defRPr>
             </a:pPr>
             <a:r>
-              <a:t>03 / 12</a:t>
+              <a:t>03 / 13</a:t>
             </a:r>
           </a:p>
         </p:txBody>
@@ -9216,7 +9993,7 @@
               </a:defRPr>
             </a:pPr>
             <a:r>
-              <a:t>Projet étudiant · État documentaire au 23 septembre 2026 · Réserves et sources : 05_ETUDE_DE_MARCHE.md</a:t>
+              <a:t>Projet étudiant · État documentaire au 24 septembre 2026 · Sources : étude de marché et 09_COUTS_PRODUCTION.md</a:t>
             </a:r>
           </a:p>
         </p:txBody>
@@ -9258,7 +10035,7 @@
               </a:defRPr>
             </a:pPr>
             <a:r>
-              <a:t>04 / 12</a:t>
+              <a:t>04 / 13</a:t>
             </a:r>
           </a:p>
         </p:txBody>
@@ -9912,7 +10689,7 @@
               </a:defRPr>
             </a:pPr>
             <a:r>
-              <a:t>Projet étudiant · État documentaire au 23 septembre 2026 · Réserves et sources : 05_ETUDE_DE_MARCHE.md</a:t>
+              <a:t>Projet étudiant · État documentaire au 24 septembre 2026 · Sources : étude de marché et 09_COUTS_PRODUCTION.md</a:t>
             </a:r>
           </a:p>
         </p:txBody>
@@ -9954,7 +10731,7 @@
               </a:defRPr>
             </a:pPr>
             <a:r>
-              <a:t>05 / 12</a:t>
+              <a:t>05 / 13</a:t>
             </a:r>
           </a:p>
         </p:txBody>
@@ -10608,7 +11385,7 @@
               </a:defRPr>
             </a:pPr>
             <a:r>
-              <a:t>Projet étudiant · État documentaire au 23 septembre 2026 · Réserves et sources : 05_ETUDE_DE_MARCHE.md</a:t>
+              <a:t>Projet étudiant · État documentaire au 24 septembre 2026 · Sources : étude de marché et 09_COUTS_PRODUCTION.md</a:t>
             </a:r>
           </a:p>
         </p:txBody>
@@ -10650,7 +11427,7 @@
               </a:defRPr>
             </a:pPr>
             <a:r>
-              <a:t>06 / 12</a:t>
+              <a:t>06 / 13</a:t>
             </a:r>
           </a:p>
         </p:txBody>
@@ -11304,7 +12081,7 @@
               </a:defRPr>
             </a:pPr>
             <a:r>
-              <a:t>Projet étudiant · État documentaire au 23 septembre 2026 · Réserves et sources : 05_ETUDE_DE_MARCHE.md</a:t>
+              <a:t>Projet étudiant · État documentaire au 24 septembre 2026 · Sources : étude de marché et 09_COUTS_PRODUCTION.md</a:t>
             </a:r>
           </a:p>
         </p:txBody>
@@ -11346,7 +12123,7 @@
               </a:defRPr>
             </a:pPr>
             <a:r>
-              <a:t>07 / 12</a:t>
+              <a:t>07 / 13</a:t>
             </a:r>
           </a:p>
         </p:txBody>
@@ -12000,7 +12777,7 @@
               </a:defRPr>
             </a:pPr>
             <a:r>
-              <a:t>Projet étudiant · État documentaire au 23 septembre 2026 · Réserves et sources : 05_ETUDE_DE_MARCHE.md</a:t>
+              <a:t>Projet étudiant · État documentaire au 24 septembre 2026 · Sources : étude de marché et 09_COUTS_PRODUCTION.md</a:t>
             </a:r>
           </a:p>
         </p:txBody>
@@ -12042,7 +12819,7 @@
               </a:defRPr>
             </a:pPr>
             <a:r>
-              <a:t>08 / 12</a:t>
+              <a:t>08 / 13</a:t>
             </a:r>
           </a:p>
         </p:txBody>
@@ -12696,7 +13473,7 @@
               </a:defRPr>
             </a:pPr>
             <a:r>
-              <a:t>Projet étudiant · État documentaire au 23 septembre 2026 · Réserves et sources : 05_ETUDE_DE_MARCHE.md</a:t>
+              <a:t>Projet étudiant · État documentaire au 24 septembre 2026 · Sources : étude de marché et 09_COUTS_PRODUCTION.md</a:t>
             </a:r>
           </a:p>
         </p:txBody>
@@ -12738,7 +13515,7 @@
               </a:defRPr>
             </a:pPr>
             <a:r>
-              <a:t>09 / 12</a:t>
+              <a:t>09 / 13</a:t>
             </a:r>
           </a:p>
         </p:txBody>

</xml_diff>

<commit_message>
docs(audit): consolidate sources and refresh delivery evidence
</commit_message>
<xml_diff>
--- a/docs/rendu/2026-09-23/InfiMatch_Soutenance_2026-09-23.pptx
+++ b/docs/rendu/2026-09-23/InfiMatch_Soutenance_2026-09-23.pptx
@@ -1479,7 +1479,7 @@
           </a:p>
           <a:p>
             <a:r>
-              <a:t>Preuves : docs/proofs/discord-notifications-20260923/ . Distinguer réussite des tests et couverture. Les résultats frontend sont antérieurs, non relancés pour le changement Discord. Ce n’est pas une certification de sécurité ou une garantie sans bugs.</a:t>
+              <a:t>Preuves : docs/proofs/review-20260924/. Tests isolés et API simulées pour les parcours navigateur. Le test de sécurité a été adapté au nouveau filtrage des candidats ayant déjà postulé et fait l’objet d’une relance séparée. Pas de preuve de déploiement ou de réception email déduite de ces tests.</a:t>
             </a:r>
           </a:p>
           <a:p>
@@ -13091,7 +13091,7 @@
               </a:defRPr>
             </a:pPr>
             <a:r>
-              <a:t>Dernière campagne unitaire backend du 23 septembre</a:t>
+              <a:t>Revue locale du 24 septembre — publication distincte</a:t>
             </a:r>
           </a:p>
         </p:txBody>
@@ -13219,7 +13219,7 @@
               </a:defRPr>
             </a:pPr>
             <a:r>
-              <a:t>660 / 660</a:t>
+              <a:t>688 / 688</a:t>
             </a:r>
           </a:p>
         </p:txBody>
@@ -13261,7 +13261,7 @@
               </a:defRPr>
             </a:pPr>
             <a:r>
-              <a:t>Tests unitaires réussis. Couverture : 95,11 % des lignes, 89,98 % des branches, 82,41 % des fonctions.</a:t>
+              <a:t>Tests unitaires réussis. Couverture : 95,00 % des lignes, 90,12 % des branches, 82,63 % des fonctions.</a:t>
             </a:r>
           </a:p>
         </p:txBody>
@@ -13431,7 +13431,7 @@
               </a:defRPr>
             </a:pPr>
             <a:r>
-              <a:t>11 intégrations notifications réussies. Régressions SQL réussies. Frontend : 81/81 dans la campagne antérieure.</a:t>
+              <a:t>192 intégrations réussies. Frontend : 81/81. Parcours navigateur public et administrateur réussis.</a:t>
             </a:r>
           </a:p>
         </p:txBody>

</xml_diff>